<commit_message>
add draft and sim engine changes
</commit_message>
<xml_diff>
--- a/04_presentations/01_powerpoint/04_Jeroen_Ellen_Axel_17-03-25.pptx
+++ b/04_presentations/01_powerpoint/04_Jeroen_Ellen_Axel_17-03-25.pptx
@@ -21,6 +21,10 @@
     <p:sldId id="271" r:id="rId15"/>
     <p:sldId id="267" r:id="rId16"/>
     <p:sldId id="268" r:id="rId17"/>
+    <p:sldId id="272" r:id="rId18"/>
+    <p:sldId id="273" r:id="rId19"/>
+    <p:sldId id="274" r:id="rId20"/>
+    <p:sldId id="275" r:id="rId21"/>
   </p:sldIdLst>
   <p:sldSz cx="12192000" cy="6858000"/>
   <p:notesSz cx="6858000" cy="9144000"/>
@@ -274,7 +278,7 @@
           <a:p>
             <a:fld id="{5C1C5790-ED67-4BB7-8607-EA1DCC2EAB8A}" type="datetimeFigureOut">
               <a:rPr lang="en-US" smtClean="0"/>
-              <a:t>3/18/2026</a:t>
+              <a:t>3/19/2026</a:t>
             </a:fld>
             <a:endParaRPr lang="en-US"/>
           </a:p>
@@ -472,7 +476,7 @@
           <a:p>
             <a:fld id="{5C1C5790-ED67-4BB7-8607-EA1DCC2EAB8A}" type="datetimeFigureOut">
               <a:rPr lang="en-US" smtClean="0"/>
-              <a:t>3/18/2026</a:t>
+              <a:t>3/19/2026</a:t>
             </a:fld>
             <a:endParaRPr lang="en-US"/>
           </a:p>
@@ -680,7 +684,7 @@
           <a:p>
             <a:fld id="{5C1C5790-ED67-4BB7-8607-EA1DCC2EAB8A}" type="datetimeFigureOut">
               <a:rPr lang="en-US" smtClean="0"/>
-              <a:t>3/18/2026</a:t>
+              <a:t>3/19/2026</a:t>
             </a:fld>
             <a:endParaRPr lang="en-US"/>
           </a:p>
@@ -878,7 +882,7 @@
           <a:p>
             <a:fld id="{5C1C5790-ED67-4BB7-8607-EA1DCC2EAB8A}" type="datetimeFigureOut">
               <a:rPr lang="en-US" smtClean="0"/>
-              <a:t>3/18/2026</a:t>
+              <a:t>3/19/2026</a:t>
             </a:fld>
             <a:endParaRPr lang="en-US"/>
           </a:p>
@@ -1153,7 +1157,7 @@
           <a:p>
             <a:fld id="{5C1C5790-ED67-4BB7-8607-EA1DCC2EAB8A}" type="datetimeFigureOut">
               <a:rPr lang="en-US" smtClean="0"/>
-              <a:t>3/18/2026</a:t>
+              <a:t>3/19/2026</a:t>
             </a:fld>
             <a:endParaRPr lang="en-US"/>
           </a:p>
@@ -1418,7 +1422,7 @@
           <a:p>
             <a:fld id="{5C1C5790-ED67-4BB7-8607-EA1DCC2EAB8A}" type="datetimeFigureOut">
               <a:rPr lang="en-US" smtClean="0"/>
-              <a:t>3/18/2026</a:t>
+              <a:t>3/19/2026</a:t>
             </a:fld>
             <a:endParaRPr lang="en-US"/>
           </a:p>
@@ -1830,7 +1834,7 @@
           <a:p>
             <a:fld id="{5C1C5790-ED67-4BB7-8607-EA1DCC2EAB8A}" type="datetimeFigureOut">
               <a:rPr lang="en-US" smtClean="0"/>
-              <a:t>3/18/2026</a:t>
+              <a:t>3/19/2026</a:t>
             </a:fld>
             <a:endParaRPr lang="en-US"/>
           </a:p>
@@ -1971,7 +1975,7 @@
           <a:p>
             <a:fld id="{5C1C5790-ED67-4BB7-8607-EA1DCC2EAB8A}" type="datetimeFigureOut">
               <a:rPr lang="en-US" smtClean="0"/>
-              <a:t>3/18/2026</a:t>
+              <a:t>3/19/2026</a:t>
             </a:fld>
             <a:endParaRPr lang="en-US"/>
           </a:p>
@@ -2084,7 +2088,7 @@
           <a:p>
             <a:fld id="{5C1C5790-ED67-4BB7-8607-EA1DCC2EAB8A}" type="datetimeFigureOut">
               <a:rPr lang="en-US" smtClean="0"/>
-              <a:t>3/18/2026</a:t>
+              <a:t>3/19/2026</a:t>
             </a:fld>
             <a:endParaRPr lang="en-US"/>
           </a:p>
@@ -2395,7 +2399,7 @@
           <a:p>
             <a:fld id="{5C1C5790-ED67-4BB7-8607-EA1DCC2EAB8A}" type="datetimeFigureOut">
               <a:rPr lang="en-US" smtClean="0"/>
-              <a:t>3/18/2026</a:t>
+              <a:t>3/19/2026</a:t>
             </a:fld>
             <a:endParaRPr lang="en-US"/>
           </a:p>
@@ -2683,7 +2687,7 @@
           <a:p>
             <a:fld id="{5C1C5790-ED67-4BB7-8607-EA1DCC2EAB8A}" type="datetimeFigureOut">
               <a:rPr lang="en-US" smtClean="0"/>
-              <a:t>3/18/2026</a:t>
+              <a:t>3/19/2026</a:t>
             </a:fld>
             <a:endParaRPr lang="en-US"/>
           </a:p>
@@ -2924,7 +2928,7 @@
           <a:p>
             <a:fld id="{5C1C5790-ED67-4BB7-8607-EA1DCC2EAB8A}" type="datetimeFigureOut">
               <a:rPr lang="en-US" smtClean="0"/>
-              <a:t>3/18/2026</a:t>
+              <a:t>3/19/2026</a:t>
             </a:fld>
             <a:endParaRPr lang="en-US"/>
           </a:p>
@@ -5994,6 +5998,282 @@
 </p:sld>
 </file>
 
+<file path=ppt/slides/slide17.xml><?xml version="1.0" encoding="utf-8"?>
+<p:sld xmlns:a="http://schemas.openxmlformats.org/drawingml/2006/main" xmlns:r="http://schemas.openxmlformats.org/officeDocument/2006/relationships" xmlns:p="http://schemas.openxmlformats.org/presentationml/2006/main">
+  <p:cSld>
+    <p:spTree>
+      <p:nvGrpSpPr>
+        <p:cNvPr id="1" name=""/>
+        <p:cNvGrpSpPr/>
+        <p:nvPr/>
+      </p:nvGrpSpPr>
+      <p:grpSpPr>
+        <a:xfrm>
+          <a:off x="0" y="0"/>
+          <a:ext cx="0" cy="0"/>
+          <a:chOff x="0" y="0"/>
+          <a:chExt cx="0" cy="0"/>
+        </a:xfrm>
+      </p:grpSpPr>
+      <p:sp>
+        <p:nvSpPr>
+          <p:cNvPr id="2" name="Title 1">
+            <a:extLst>
+              <a:ext uri="{FF2B5EF4-FFF2-40B4-BE49-F238E27FC236}">
+                <a16:creationId xmlns:a16="http://schemas.microsoft.com/office/drawing/2014/main" id="{1AC8A361-B1F3-7E9C-5553-051AD4F338A4}"/>
+              </a:ext>
+            </a:extLst>
+          </p:cNvPr>
+          <p:cNvSpPr>
+            <a:spLocks noGrp="1"/>
+          </p:cNvSpPr>
+          <p:nvPr>
+            <p:ph type="title"/>
+          </p:nvPr>
+        </p:nvSpPr>
+        <p:spPr/>
+        <p:txBody>
+          <a:bodyPr/>
+          <a:lstStyle/>
+          <a:p>
+            <a:r>
+              <a:rPr lang="en-US" dirty="0"/>
+              <a:t>Sim study 1 (N=5000)</a:t>
+            </a:r>
+          </a:p>
+        </p:txBody>
+      </p:sp>
+      <p:pic>
+        <p:nvPicPr>
+          <p:cNvPr id="7" name="Picture 6">
+            <a:extLst>
+              <a:ext uri="{FF2B5EF4-FFF2-40B4-BE49-F238E27FC236}">
+                <a16:creationId xmlns:a16="http://schemas.microsoft.com/office/drawing/2014/main" id="{2641382C-EFA4-B327-C8A2-DCFD5787FF3A}"/>
+              </a:ext>
+            </a:extLst>
+          </p:cNvPr>
+          <p:cNvPicPr>
+            <a:picLocks noChangeAspect="1"/>
+          </p:cNvPicPr>
+          <p:nvPr/>
+        </p:nvPicPr>
+        <p:blipFill>
+          <a:blip r:embed="rId2"/>
+          <a:stretch>
+            <a:fillRect/>
+          </a:stretch>
+        </p:blipFill>
+        <p:spPr>
+          <a:xfrm>
+            <a:off x="838200" y="1536833"/>
+            <a:ext cx="6638925" cy="4419600"/>
+          </a:xfrm>
+          <a:prstGeom prst="rect">
+            <a:avLst/>
+          </a:prstGeom>
+        </p:spPr>
+      </p:pic>
+    </p:spTree>
+    <p:extLst>
+      <p:ext uri="{BB962C8B-B14F-4D97-AF65-F5344CB8AC3E}">
+        <p14:creationId xmlns:p14="http://schemas.microsoft.com/office/powerpoint/2010/main" val="3450178542"/>
+      </p:ext>
+    </p:extLst>
+  </p:cSld>
+  <p:clrMapOvr>
+    <a:masterClrMapping/>
+  </p:clrMapOvr>
+</p:sld>
+</file>
+
+<file path=ppt/slides/slide18.xml><?xml version="1.0" encoding="utf-8"?>
+<p:sld xmlns:a="http://schemas.openxmlformats.org/drawingml/2006/main" xmlns:r="http://schemas.openxmlformats.org/officeDocument/2006/relationships" xmlns:p="http://schemas.openxmlformats.org/presentationml/2006/main">
+  <p:cSld>
+    <p:spTree>
+      <p:nvGrpSpPr>
+        <p:cNvPr id="1" name="">
+          <a:extLst>
+            <a:ext uri="{FF2B5EF4-FFF2-40B4-BE49-F238E27FC236}">
+              <a16:creationId xmlns:a16="http://schemas.microsoft.com/office/drawing/2014/main" id="{7C8D0299-FAFC-A03F-481E-B3C0BC6EC255}"/>
+            </a:ext>
+          </a:extLst>
+        </p:cNvPr>
+        <p:cNvGrpSpPr/>
+        <p:nvPr/>
+      </p:nvGrpSpPr>
+      <p:grpSpPr>
+        <a:xfrm>
+          <a:off x="0" y="0"/>
+          <a:ext cx="0" cy="0"/>
+          <a:chOff x="0" y="0"/>
+          <a:chExt cx="0" cy="0"/>
+        </a:xfrm>
+      </p:grpSpPr>
+      <p:sp>
+        <p:nvSpPr>
+          <p:cNvPr id="2" name="Title 1">
+            <a:extLst>
+              <a:ext uri="{FF2B5EF4-FFF2-40B4-BE49-F238E27FC236}">
+                <a16:creationId xmlns:a16="http://schemas.microsoft.com/office/drawing/2014/main" id="{4F9F8A9E-14D9-D709-DC92-65F3C70C2612}"/>
+              </a:ext>
+            </a:extLst>
+          </p:cNvPr>
+          <p:cNvSpPr>
+            <a:spLocks noGrp="1"/>
+          </p:cNvSpPr>
+          <p:nvPr>
+            <p:ph type="title"/>
+          </p:nvPr>
+        </p:nvSpPr>
+        <p:spPr/>
+        <p:txBody>
+          <a:bodyPr/>
+          <a:lstStyle/>
+          <a:p>
+            <a:r>
+              <a:rPr lang="en-US" dirty="0"/>
+              <a:t>Sim study 1 (N=5000)</a:t>
+            </a:r>
+          </a:p>
+        </p:txBody>
+      </p:sp>
+      <p:pic>
+        <p:nvPicPr>
+          <p:cNvPr id="4" name="Picture 3">
+            <a:extLst>
+              <a:ext uri="{FF2B5EF4-FFF2-40B4-BE49-F238E27FC236}">
+                <a16:creationId xmlns:a16="http://schemas.microsoft.com/office/drawing/2014/main" id="{99F1A2A1-A555-F875-FF7A-76A210E23B39}"/>
+              </a:ext>
+            </a:extLst>
+          </p:cNvPr>
+          <p:cNvPicPr>
+            <a:picLocks noChangeAspect="1"/>
+          </p:cNvPicPr>
+          <p:nvPr/>
+        </p:nvPicPr>
+        <p:blipFill>
+          <a:blip r:embed="rId2"/>
+          <a:stretch>
+            <a:fillRect/>
+          </a:stretch>
+        </p:blipFill>
+        <p:spPr>
+          <a:xfrm>
+            <a:off x="838200" y="1556084"/>
+            <a:ext cx="6638925" cy="4419600"/>
+          </a:xfrm>
+          <a:prstGeom prst="rect">
+            <a:avLst/>
+          </a:prstGeom>
+        </p:spPr>
+      </p:pic>
+    </p:spTree>
+    <p:extLst>
+      <p:ext uri="{BB962C8B-B14F-4D97-AF65-F5344CB8AC3E}">
+        <p14:creationId xmlns:p14="http://schemas.microsoft.com/office/powerpoint/2010/main" val="2417137567"/>
+      </p:ext>
+    </p:extLst>
+  </p:cSld>
+  <p:clrMapOvr>
+    <a:masterClrMapping/>
+  </p:clrMapOvr>
+</p:sld>
+</file>
+
+<file path=ppt/slides/slide19.xml><?xml version="1.0" encoding="utf-8"?>
+<p:sld xmlns:a="http://schemas.openxmlformats.org/drawingml/2006/main" xmlns:r="http://schemas.openxmlformats.org/officeDocument/2006/relationships" xmlns:p="http://schemas.openxmlformats.org/presentationml/2006/main">
+  <p:cSld>
+    <p:spTree>
+      <p:nvGrpSpPr>
+        <p:cNvPr id="1" name="">
+          <a:extLst>
+            <a:ext uri="{FF2B5EF4-FFF2-40B4-BE49-F238E27FC236}">
+              <a16:creationId xmlns:a16="http://schemas.microsoft.com/office/drawing/2014/main" id="{B4E3E4A2-F389-BE76-FEB3-7E13A659FD30}"/>
+            </a:ext>
+          </a:extLst>
+        </p:cNvPr>
+        <p:cNvGrpSpPr/>
+        <p:nvPr/>
+      </p:nvGrpSpPr>
+      <p:grpSpPr>
+        <a:xfrm>
+          <a:off x="0" y="0"/>
+          <a:ext cx="0" cy="0"/>
+          <a:chOff x="0" y="0"/>
+          <a:chExt cx="0" cy="0"/>
+        </a:xfrm>
+      </p:grpSpPr>
+      <p:sp>
+        <p:nvSpPr>
+          <p:cNvPr id="2" name="Title 1">
+            <a:extLst>
+              <a:ext uri="{FF2B5EF4-FFF2-40B4-BE49-F238E27FC236}">
+                <a16:creationId xmlns:a16="http://schemas.microsoft.com/office/drawing/2014/main" id="{B0F3C417-A184-9EA5-9F88-49FC34DD3C18}"/>
+              </a:ext>
+            </a:extLst>
+          </p:cNvPr>
+          <p:cNvSpPr>
+            <a:spLocks noGrp="1"/>
+          </p:cNvSpPr>
+          <p:nvPr>
+            <p:ph type="title"/>
+          </p:nvPr>
+        </p:nvSpPr>
+        <p:spPr/>
+        <p:txBody>
+          <a:bodyPr/>
+          <a:lstStyle/>
+          <a:p>
+            <a:r>
+              <a:rPr lang="en-US" dirty="0"/>
+              <a:t>Sim study 2 (N=300)</a:t>
+            </a:r>
+          </a:p>
+        </p:txBody>
+      </p:sp>
+      <p:pic>
+        <p:nvPicPr>
+          <p:cNvPr id="4" name="Picture 3">
+            <a:extLst>
+              <a:ext uri="{FF2B5EF4-FFF2-40B4-BE49-F238E27FC236}">
+                <a16:creationId xmlns:a16="http://schemas.microsoft.com/office/drawing/2014/main" id="{9B57D636-ABD2-401D-1850-05335403D063}"/>
+              </a:ext>
+            </a:extLst>
+          </p:cNvPr>
+          <p:cNvPicPr>
+            <a:picLocks noChangeAspect="1"/>
+          </p:cNvPicPr>
+          <p:nvPr/>
+        </p:nvPicPr>
+        <p:blipFill>
+          <a:blip r:embed="rId2"/>
+          <a:stretch>
+            <a:fillRect/>
+          </a:stretch>
+        </p:blipFill>
+        <p:spPr>
+          <a:xfrm>
+            <a:off x="770152" y="1654593"/>
+            <a:ext cx="6638925" cy="4419600"/>
+          </a:xfrm>
+          <a:prstGeom prst="rect">
+            <a:avLst/>
+          </a:prstGeom>
+        </p:spPr>
+      </p:pic>
+    </p:spTree>
+    <p:extLst>
+      <p:ext uri="{BB962C8B-B14F-4D97-AF65-F5344CB8AC3E}">
+        <p14:creationId xmlns:p14="http://schemas.microsoft.com/office/powerpoint/2010/main" val="3803704947"/>
+      </p:ext>
+    </p:extLst>
+  </p:cSld>
+  <p:clrMapOvr>
+    <a:masterClrMapping/>
+  </p:clrMapOvr>
+</p:sld>
+</file>
+
 <file path=ppt/slides/slide2.xml><?xml version="1.0" encoding="utf-8"?>
 <p:sld xmlns:a="http://schemas.openxmlformats.org/drawingml/2006/main" xmlns:r="http://schemas.openxmlformats.org/officeDocument/2006/relationships" xmlns:p="http://schemas.openxmlformats.org/presentationml/2006/main">
   <p:cSld>
@@ -6165,6 +6445,100 @@
     <p:extLst>
       <p:ext uri="{BB962C8B-B14F-4D97-AF65-F5344CB8AC3E}">
         <p14:creationId xmlns:p14="http://schemas.microsoft.com/office/powerpoint/2010/main" val="2834703173"/>
+      </p:ext>
+    </p:extLst>
+  </p:cSld>
+  <p:clrMapOvr>
+    <a:masterClrMapping/>
+  </p:clrMapOvr>
+</p:sld>
+</file>
+
+<file path=ppt/slides/slide20.xml><?xml version="1.0" encoding="utf-8"?>
+<p:sld xmlns:a="http://schemas.openxmlformats.org/drawingml/2006/main" xmlns:r="http://schemas.openxmlformats.org/officeDocument/2006/relationships" xmlns:p="http://schemas.openxmlformats.org/presentationml/2006/main">
+  <p:cSld>
+    <p:spTree>
+      <p:nvGrpSpPr>
+        <p:cNvPr id="1" name="">
+          <a:extLst>
+            <a:ext uri="{FF2B5EF4-FFF2-40B4-BE49-F238E27FC236}">
+              <a16:creationId xmlns:a16="http://schemas.microsoft.com/office/drawing/2014/main" id="{F6521FFE-3E1F-BA35-547E-8E21C39DF329}"/>
+            </a:ext>
+          </a:extLst>
+        </p:cNvPr>
+        <p:cNvGrpSpPr/>
+        <p:nvPr/>
+      </p:nvGrpSpPr>
+      <p:grpSpPr>
+        <a:xfrm>
+          <a:off x="0" y="0"/>
+          <a:ext cx="0" cy="0"/>
+          <a:chOff x="0" y="0"/>
+          <a:chExt cx="0" cy="0"/>
+        </a:xfrm>
+      </p:grpSpPr>
+      <p:sp>
+        <p:nvSpPr>
+          <p:cNvPr id="2" name="Title 1">
+            <a:extLst>
+              <a:ext uri="{FF2B5EF4-FFF2-40B4-BE49-F238E27FC236}">
+                <a16:creationId xmlns:a16="http://schemas.microsoft.com/office/drawing/2014/main" id="{92D8819C-D6F2-28D5-8993-9341643E968D}"/>
+              </a:ext>
+            </a:extLst>
+          </p:cNvPr>
+          <p:cNvSpPr>
+            <a:spLocks noGrp="1"/>
+          </p:cNvSpPr>
+          <p:nvPr>
+            <p:ph type="title"/>
+          </p:nvPr>
+        </p:nvSpPr>
+        <p:spPr/>
+        <p:txBody>
+          <a:bodyPr/>
+          <a:lstStyle/>
+          <a:p>
+            <a:r>
+              <a:rPr lang="en-US" dirty="0"/>
+              <a:t>Sim study 2 (N=300)</a:t>
+            </a:r>
+          </a:p>
+        </p:txBody>
+      </p:sp>
+      <p:pic>
+        <p:nvPicPr>
+          <p:cNvPr id="5" name="Picture 4">
+            <a:extLst>
+              <a:ext uri="{FF2B5EF4-FFF2-40B4-BE49-F238E27FC236}">
+                <a16:creationId xmlns:a16="http://schemas.microsoft.com/office/drawing/2014/main" id="{2F380DC3-E7CD-0174-8062-EE3D8FA7113B}"/>
+              </a:ext>
+            </a:extLst>
+          </p:cNvPr>
+          <p:cNvPicPr>
+            <a:picLocks noChangeAspect="1"/>
+          </p:cNvPicPr>
+          <p:nvPr/>
+        </p:nvPicPr>
+        <p:blipFill>
+          <a:blip r:embed="rId2"/>
+          <a:stretch>
+            <a:fillRect/>
+          </a:stretch>
+        </p:blipFill>
+        <p:spPr>
+          <a:xfrm>
+            <a:off x="838200" y="1517584"/>
+            <a:ext cx="6638925" cy="4419600"/>
+          </a:xfrm>
+          <a:prstGeom prst="rect">
+            <a:avLst/>
+          </a:prstGeom>
+        </p:spPr>
+      </p:pic>
+    </p:spTree>
+    <p:extLst>
+      <p:ext uri="{BB962C8B-B14F-4D97-AF65-F5344CB8AC3E}">
+        <p14:creationId xmlns:p14="http://schemas.microsoft.com/office/powerpoint/2010/main" val="2294117833"/>
       </p:ext>
     </p:extLst>
   </p:cSld>

</xml_diff>